<commit_message>
Complete native shared project workflows and qualify local design updates
</commit_message>
<xml_diff>
--- a/tests/fixtures/rebrand/notes.pptx
+++ b/tests/fixtures/rebrand/notes.pptx
@@ -160,8 +160,9 @@
               <a:rPr lang="en-US" dirty="0"/>
               <a:t>Pause here.</a:t>
             </a:r>
-          </a:p>
-          <a:p>
+            <a:br>
+              <a:rPr lang="en-US" dirty="0"/>
+            </a:br>
             <a:r>
               <a:rPr lang="en-US" dirty="0"/>
               <a:t>Ask the room before moving on.</a:t>

</xml_diff>

<commit_message>
Add live Comments presence and deck collaborator invitations
</commit_message>
<xml_diff>
--- a/tests/fixtures/rebrand/notes.pptx
+++ b/tests/fixtures/rebrand/notes.pptx
@@ -160,9 +160,8 @@
               <a:rPr lang="en-US" dirty="0"/>
               <a:t>Pause here.</a:t>
             </a:r>
-            <a:br>
-              <a:rPr lang="en-US" dirty="0"/>
-            </a:br>
+          </a:p>
+          <a:p>
             <a:r>
               <a:rPr lang="en-US" dirty="0"/>
               <a:t>Ask the room before moving on.</a:t>

</xml_diff>